<commit_message>
day 5 of terraform training
</commit_message>
<xml_diff>
--- a/day4/day4_version_constraints_iam.pptx
+++ b/day4/day4_version_constraints_iam.pptx
@@ -5,19 +5,18 @@
     <p:sldMasterId id="2147483648" r:id="rId1"/>
   </p:sldMasterIdLst>
   <p:notesMasterIdLst>
-    <p:notesMasterId r:id="rId12"/>
+    <p:notesMasterId r:id="rId11"/>
   </p:notesMasterIdLst>
   <p:sldIdLst>
     <p:sldId id="256" r:id="rId2"/>
     <p:sldId id="257" r:id="rId3"/>
     <p:sldId id="258" r:id="rId4"/>
-    <p:sldId id="267" r:id="rId5"/>
-    <p:sldId id="259" r:id="rId6"/>
-    <p:sldId id="261" r:id="rId7"/>
-    <p:sldId id="263" r:id="rId8"/>
-    <p:sldId id="264" r:id="rId9"/>
-    <p:sldId id="265" r:id="rId10"/>
-    <p:sldId id="266" r:id="rId11"/>
+    <p:sldId id="259" r:id="rId5"/>
+    <p:sldId id="261" r:id="rId6"/>
+    <p:sldId id="263" r:id="rId7"/>
+    <p:sldId id="264" r:id="rId8"/>
+    <p:sldId id="265" r:id="rId9"/>
+    <p:sldId id="266" r:id="rId10"/>
   </p:sldIdLst>
   <p:sldSz cx="12192000" cy="6858000"/>
   <p:notesSz cx="6858000" cy="12192000"/>
@@ -563,7 +562,7 @@
           <a:p>
             <a:fld id="{F7021451-1387-4CA6-816F-3879F97B5CBC}" type="slidenum">
               <a:rPr lang="en-US"/>
-              <a:t>5</a:t>
+              <a:t>4</a:t>
             </a:fld>
             <a:endParaRPr lang="en-US"/>
           </a:p>
@@ -647,7 +646,7 @@
           <a:p>
             <a:fld id="{F7021451-1387-4CA6-816F-3879F97B5CBC}" type="slidenum">
               <a:rPr lang="en-US"/>
-              <a:t>6</a:t>
+              <a:t>5</a:t>
             </a:fld>
             <a:endParaRPr lang="en-US"/>
           </a:p>
@@ -731,7 +730,7 @@
           <a:p>
             <a:fld id="{F7021451-1387-4CA6-816F-3879F97B5CBC}" type="slidenum">
               <a:rPr lang="en-US"/>
-              <a:t>7</a:t>
+              <a:t>6</a:t>
             </a:fld>
             <a:endParaRPr lang="en-US"/>
           </a:p>
@@ -815,7 +814,7 @@
           <a:p>
             <a:fld id="{F7021451-1387-4CA6-816F-3879F97B5CBC}" type="slidenum">
               <a:rPr lang="en-US"/>
-              <a:t>8</a:t>
+              <a:t>7</a:t>
             </a:fld>
             <a:endParaRPr lang="en-US"/>
           </a:p>
@@ -899,7 +898,7 @@
           <a:p>
             <a:fld id="{F7021451-1387-4CA6-816F-3879F97B5CBC}" type="slidenum">
               <a:rPr lang="en-US"/>
-              <a:t>9</a:t>
+              <a:t>8</a:t>
             </a:fld>
             <a:endParaRPr lang="en-US"/>
           </a:p>
@@ -983,7 +982,7 @@
           <a:p>
             <a:fld id="{F7021451-1387-4CA6-816F-3879F97B5CBC}" type="slidenum">
               <a:rPr lang="en-US"/>
-              <a:t>10</a:t>
+              <a:t>9</a:t>
             </a:fld>
             <a:endParaRPr lang="en-US"/>
           </a:p>
@@ -1730,689 +1729,6 @@
 </p:sld>
 </file>
 
-<file path=ppt/slides/slide10.xml><?xml version="1.0" encoding="utf-8"?>
-<p:sld xmlns:a="http://schemas.openxmlformats.org/drawingml/2006/main" xmlns:r="http://schemas.openxmlformats.org/officeDocument/2006/relationships" xmlns:p="http://schemas.openxmlformats.org/presentationml/2006/main">
-  <p:cSld name="Slide 11">
-    <p:bg>
-      <p:bgPr>
-        <a:solidFill>
-          <a:srgbClr val="FFFFFF"/>
-        </a:solidFill>
-        <a:effectLst/>
-      </p:bgPr>
-    </p:bg>
-    <p:spTree>
-      <p:nvGrpSpPr>
-        <p:cNvPr id="1" name=""/>
-        <p:cNvGrpSpPr/>
-        <p:nvPr/>
-      </p:nvGrpSpPr>
-      <p:grpSpPr>
-        <a:xfrm>
-          <a:off x="0" y="0"/>
-          <a:ext cx="0" cy="0"/>
-          <a:chOff x="0" y="0"/>
-          <a:chExt cx="0" cy="0"/>
-        </a:xfrm>
-      </p:grpSpPr>
-      <p:sp>
-        <p:nvSpPr>
-          <p:cNvPr id="2" name="Text 0"/>
-          <p:cNvSpPr/>
-          <p:nvPr/>
-        </p:nvSpPr>
-        <p:spPr>
-          <a:xfrm>
-            <a:off x="7955280" y="-502920"/>
-            <a:ext cx="3383280" cy="2377440"/>
-          </a:xfrm>
-          <a:prstGeom prst="rect">
-            <a:avLst/>
-          </a:prstGeom>
-          <a:noFill/>
-          <a:ln/>
-        </p:spPr>
-        <p:txBody>
-          <a:bodyPr wrap="square" rtlCol="0" anchor="ctr"/>
-          <a:lstStyle/>
-          <a:p>
-            <a:pPr marL="0" indent="0" algn="r">
-              <a:buNone/>
-            </a:pPr>
-            <a:r>
-              <a:rPr lang="en-US" sz="15000" b="1" dirty="0">
-                <a:solidFill>
-                  <a:srgbClr val="EEEFF3"/>
-                </a:solidFill>
-                <a:latin typeface="Century Schoolbook" pitchFamily="34" charset="0"/>
-                <a:ea typeface="Century Schoolbook" pitchFamily="34" charset="-122"/>
-                <a:cs typeface="Century Schoolbook" pitchFamily="34" charset="-120"/>
-              </a:rPr>
-              <a:t>09</a:t>
-            </a:r>
-            <a:endParaRPr lang="en-US" sz="15000" dirty="0"/>
-          </a:p>
-        </p:txBody>
-      </p:sp>
-      <p:sp>
-        <p:nvSpPr>
-          <p:cNvPr id="3" name="Shape 1"/>
-          <p:cNvSpPr/>
-          <p:nvPr/>
-        </p:nvSpPr>
-        <p:spPr>
-          <a:xfrm>
-            <a:off x="822960" y="868680"/>
-            <a:ext cx="137160" cy="137160"/>
-          </a:xfrm>
-          <a:prstGeom prst="rect">
-            <a:avLst/>
-          </a:prstGeom>
-          <a:solidFill>
-            <a:srgbClr val="6E4B84"/>
-          </a:solidFill>
-          <a:ln/>
-        </p:spPr>
-        <p:txBody>
-          <a:bodyPr/>
-          <a:lstStyle/>
-          <a:p>
-            <a:endParaRPr lang="en-IN"/>
-          </a:p>
-        </p:txBody>
-      </p:sp>
-      <p:sp>
-        <p:nvSpPr>
-          <p:cNvPr id="4" name="Text 2"/>
-          <p:cNvSpPr/>
-          <p:nvPr/>
-        </p:nvSpPr>
-        <p:spPr>
-          <a:xfrm>
-            <a:off x="1078992" y="795528"/>
-            <a:ext cx="8229600" cy="292608"/>
-          </a:xfrm>
-          <a:prstGeom prst="rect">
-            <a:avLst/>
-          </a:prstGeom>
-          <a:noFill/>
-          <a:ln/>
-        </p:spPr>
-        <p:txBody>
-          <a:bodyPr wrap="square" rtlCol="0" anchor="ctr"/>
-          <a:lstStyle/>
-          <a:p>
-            <a:pPr marL="0" indent="0">
-              <a:buNone/>
-            </a:pPr>
-            <a:r>
-              <a:rPr lang="en-US" sz="1100" b="1" kern="0" spc="250" dirty="0">
-                <a:solidFill>
-                  <a:srgbClr val="6E4B84"/>
-                </a:solidFill>
-                <a:latin typeface="Calibri" pitchFamily="34" charset="0"/>
-                <a:ea typeface="Calibri" pitchFamily="34" charset="-122"/>
-                <a:cs typeface="Calibri" pitchFamily="34" charset="-120"/>
-              </a:rPr>
-              <a:t>THE STEP THAT'S EASY TO FORGET</a:t>
-            </a:r>
-            <a:endParaRPr lang="en-US" sz="1100" dirty="0"/>
-          </a:p>
-        </p:txBody>
-      </p:sp>
-      <p:sp>
-        <p:nvSpPr>
-          <p:cNvPr id="5" name="Text 3"/>
-          <p:cNvSpPr/>
-          <p:nvPr/>
-        </p:nvSpPr>
-        <p:spPr>
-          <a:xfrm>
-            <a:off x="795528" y="1115568"/>
-            <a:ext cx="8778240" cy="822960"/>
-          </a:xfrm>
-          <a:prstGeom prst="rect">
-            <a:avLst/>
-          </a:prstGeom>
-          <a:noFill/>
-          <a:ln/>
-        </p:spPr>
-        <p:txBody>
-          <a:bodyPr wrap="square" rtlCol="0" anchor="ctr"/>
-          <a:lstStyle/>
-          <a:p>
-            <a:pPr marL="0" indent="0">
-              <a:buNone/>
-            </a:pPr>
-            <a:r>
-              <a:rPr lang="en-US" sz="3300" b="1" dirty="0">
-                <a:solidFill>
-                  <a:srgbClr val="1F2430"/>
-                </a:solidFill>
-                <a:latin typeface="Century Schoolbook" pitchFamily="34" charset="0"/>
-                <a:ea typeface="Century Schoolbook" pitchFamily="34" charset="-122"/>
-                <a:cs typeface="Century Schoolbook" pitchFamily="34" charset="-120"/>
-              </a:rPr>
-              <a:t>Attaching a policy to a role</a:t>
-            </a:r>
-            <a:endParaRPr lang="en-US" sz="3300" dirty="0"/>
-          </a:p>
-        </p:txBody>
-      </p:sp>
-      <p:sp>
-        <p:nvSpPr>
-          <p:cNvPr id="6" name="Shape 4"/>
-          <p:cNvSpPr/>
-          <p:nvPr/>
-        </p:nvSpPr>
-        <p:spPr>
-          <a:xfrm>
-            <a:off x="822960" y="2148840"/>
-            <a:ext cx="10543032" cy="2514600"/>
-          </a:xfrm>
-          <a:prstGeom prst="roundRect">
-            <a:avLst>
-              <a:gd name="adj" fmla="val 2182"/>
-            </a:avLst>
-          </a:prstGeom>
-          <a:solidFill>
-            <a:srgbClr val="F6F7F9"/>
-          </a:solidFill>
-          <a:ln w="12700">
-            <a:solidFill>
-              <a:srgbClr val="E1E4E9"/>
-            </a:solidFill>
-            <a:prstDash val="solid"/>
-          </a:ln>
-        </p:spPr>
-        <p:txBody>
-          <a:bodyPr/>
-          <a:lstStyle/>
-          <a:p>
-            <a:endParaRPr lang="en-IN"/>
-          </a:p>
-        </p:txBody>
-      </p:sp>
-      <p:sp>
-        <p:nvSpPr>
-          <p:cNvPr id="7" name="Shape 5"/>
-          <p:cNvSpPr/>
-          <p:nvPr/>
-        </p:nvSpPr>
-        <p:spPr>
-          <a:xfrm>
-            <a:off x="1051560" y="2002536"/>
-            <a:ext cx="947318" cy="310896"/>
-          </a:xfrm>
-          <a:prstGeom prst="roundRect">
-            <a:avLst>
-              <a:gd name="adj" fmla="val 14706"/>
-            </a:avLst>
-          </a:prstGeom>
-          <a:solidFill>
-            <a:srgbClr val="1F2430"/>
-          </a:solidFill>
-          <a:ln/>
-        </p:spPr>
-        <p:txBody>
-          <a:bodyPr/>
-          <a:lstStyle/>
-          <a:p>
-            <a:endParaRPr lang="en-IN"/>
-          </a:p>
-        </p:txBody>
-      </p:sp>
-      <p:sp>
-        <p:nvSpPr>
-          <p:cNvPr id="8" name="Text 6"/>
-          <p:cNvSpPr/>
-          <p:nvPr/>
-        </p:nvSpPr>
-        <p:spPr>
-          <a:xfrm>
-            <a:off x="1051560" y="2002536"/>
-            <a:ext cx="947318" cy="310896"/>
-          </a:xfrm>
-          <a:prstGeom prst="rect">
-            <a:avLst/>
-          </a:prstGeom>
-          <a:noFill/>
-          <a:ln/>
-        </p:spPr>
-        <p:txBody>
-          <a:bodyPr wrap="square" rtlCol="0" anchor="ctr"/>
-          <a:lstStyle/>
-          <a:p>
-            <a:pPr marL="0" indent="0" algn="ctr">
-              <a:buNone/>
-            </a:pPr>
-            <a:r>
-              <a:rPr lang="en-US" sz="1000" dirty="0">
-                <a:solidFill>
-                  <a:srgbClr val="FFFFFF"/>
-                </a:solidFill>
-                <a:latin typeface="Courier New" pitchFamily="34" charset="0"/>
-                <a:ea typeface="Courier New" pitchFamily="34" charset="-122"/>
-                <a:cs typeface="Courier New" pitchFamily="34" charset="-120"/>
-              </a:rPr>
-              <a:t>main.tf</a:t>
-            </a:r>
-            <a:endParaRPr lang="en-US" sz="1000" dirty="0"/>
-          </a:p>
-        </p:txBody>
-      </p:sp>
-      <p:sp>
-        <p:nvSpPr>
-          <p:cNvPr id="9" name="Text 7"/>
-          <p:cNvSpPr/>
-          <p:nvPr/>
-        </p:nvSpPr>
-        <p:spPr>
-          <a:xfrm>
-            <a:off x="1097280" y="2459736"/>
-            <a:ext cx="9994392" cy="2057400"/>
-          </a:xfrm>
-          <a:prstGeom prst="rect">
-            <a:avLst/>
-          </a:prstGeom>
-          <a:noFill/>
-          <a:ln/>
-        </p:spPr>
-        <p:txBody>
-          <a:bodyPr wrap="square" rtlCol="0" anchor="t"/>
-          <a:lstStyle/>
-          <a:p>
-            <a:pPr marL="0" indent="0" algn="l">
-              <a:lnSpc>
-                <a:spcPct val="118000"/>
-              </a:lnSpc>
-              <a:buNone/>
-            </a:pPr>
-            <a:r>
-              <a:rPr lang="en-US" sz="1250" dirty="0">
-                <a:solidFill>
-                  <a:srgbClr val="2E5A7E"/>
-                </a:solidFill>
-                <a:latin typeface="Courier New" pitchFamily="34" charset="0"/>
-                <a:ea typeface="Courier New" pitchFamily="34" charset="-122"/>
-                <a:cs typeface="Courier New" pitchFamily="34" charset="-120"/>
-              </a:rPr>
-              <a:t>resource </a:t>
-            </a:r>
-            <a:r>
-              <a:rPr lang="en-US" sz="1250" dirty="0">
-                <a:solidFill>
-                  <a:srgbClr val="9C6621"/>
-                </a:solidFill>
-                <a:latin typeface="Courier New" pitchFamily="34" charset="0"/>
-                <a:ea typeface="Courier New" pitchFamily="34" charset="-122"/>
-                <a:cs typeface="Courier New" pitchFamily="34" charset="-120"/>
-              </a:rPr>
-              <a:t>"aws_iam_policy"</a:t>
-            </a:r>
-            <a:r>
-              <a:rPr lang="en-US" sz="1250" dirty="0">
-                <a:solidFill>
-                  <a:srgbClr val="1F2430"/>
-                </a:solidFill>
-                <a:latin typeface="Courier New" pitchFamily="34" charset="0"/>
-                <a:ea typeface="Courier New" pitchFamily="34" charset="-122"/>
-                <a:cs typeface="Courier New" pitchFamily="34" charset="-120"/>
-              </a:rPr>
-              <a:t> </a:t>
-            </a:r>
-            <a:r>
-              <a:rPr lang="en-US" sz="1250" dirty="0">
-                <a:solidFill>
-                  <a:srgbClr val="9C6621"/>
-                </a:solidFill>
-                <a:latin typeface="Courier New" pitchFamily="34" charset="0"/>
-                <a:ea typeface="Courier New" pitchFamily="34" charset="-122"/>
-                <a:cs typeface="Courier New" pitchFamily="34" charset="-120"/>
-              </a:rPr>
-              <a:t>"s3_read_only"</a:t>
-            </a:r>
-            <a:r>
-              <a:rPr lang="en-US" sz="1250" dirty="0">
-                <a:solidFill>
-                  <a:srgbClr val="1F2430"/>
-                </a:solidFill>
-                <a:latin typeface="Courier New" pitchFamily="34" charset="0"/>
-                <a:ea typeface="Courier New" pitchFamily="34" charset="-122"/>
-                <a:cs typeface="Courier New" pitchFamily="34" charset="-120"/>
-              </a:rPr>
-              <a:t> {
-  name   </a:t>
-            </a:r>
-            <a:r>
-              <a:rPr lang="en-US" sz="1250" dirty="0">
-                <a:solidFill>
-                  <a:srgbClr val="9AA1AD"/>
-                </a:solidFill>
-                <a:latin typeface="Courier New" pitchFamily="34" charset="0"/>
-                <a:ea typeface="Courier New" pitchFamily="34" charset="-122"/>
-                <a:cs typeface="Courier New" pitchFamily="34" charset="-120"/>
-              </a:rPr>
-              <a:t>= </a:t>
-            </a:r>
-            <a:r>
-              <a:rPr lang="en-US" sz="1250" dirty="0">
-                <a:solidFill>
-                  <a:srgbClr val="9C6621"/>
-                </a:solidFill>
-                <a:latin typeface="Courier New" pitchFamily="34" charset="0"/>
-                <a:ea typeface="Courier New" pitchFamily="34" charset="-122"/>
-                <a:cs typeface="Courier New" pitchFamily="34" charset="-120"/>
-              </a:rPr>
-              <a:t>"my-role-s3-read-only"
-</a:t>
-            </a:r>
-            <a:r>
-              <a:rPr lang="en-US" sz="1250" dirty="0">
-                <a:solidFill>
-                  <a:srgbClr val="1F2430"/>
-                </a:solidFill>
-                <a:latin typeface="Courier New" pitchFamily="34" charset="0"/>
-                <a:ea typeface="Courier New" pitchFamily="34" charset="-122"/>
-                <a:cs typeface="Courier New" pitchFamily="34" charset="-120"/>
-              </a:rPr>
-              <a:t>  policy </a:t>
-            </a:r>
-            <a:r>
-              <a:rPr lang="en-US" sz="1250" dirty="0">
-                <a:solidFill>
-                  <a:srgbClr val="9AA1AD"/>
-                </a:solidFill>
-                <a:latin typeface="Courier New" pitchFamily="34" charset="0"/>
-                <a:ea typeface="Courier New" pitchFamily="34" charset="-122"/>
-                <a:cs typeface="Courier New" pitchFamily="34" charset="-120"/>
-              </a:rPr>
-              <a:t>= </a:t>
-            </a:r>
-            <a:r>
-              <a:rPr lang="en-US" sz="1250" dirty="0">
-                <a:solidFill>
-                  <a:srgbClr val="3C6E5C"/>
-                </a:solidFill>
-                <a:latin typeface="Courier New" pitchFamily="34" charset="0"/>
-                <a:ea typeface="Courier New" pitchFamily="34" charset="-122"/>
-                <a:cs typeface="Courier New" pitchFamily="34" charset="-120"/>
-              </a:rPr>
-              <a:t>data.aws_iam_policy_document.s3_read_only.json
-</a:t>
-            </a:r>
-            <a:r>
-              <a:rPr lang="en-US" sz="1250" dirty="0">
-                <a:solidFill>
-                  <a:srgbClr val="1F2430"/>
-                </a:solidFill>
-                <a:latin typeface="Courier New" pitchFamily="34" charset="0"/>
-                <a:ea typeface="Courier New" pitchFamily="34" charset="-122"/>
-                <a:cs typeface="Courier New" pitchFamily="34" charset="-120"/>
-              </a:rPr>
-              <a:t>}
-</a:t>
-            </a:r>
-            <a:r>
-              <a:rPr lang="en-US" sz="1250" dirty="0">
-                <a:solidFill>
-                  <a:srgbClr val="2E5A7E"/>
-                </a:solidFill>
-                <a:latin typeface="Courier New" pitchFamily="34" charset="0"/>
-                <a:ea typeface="Courier New" pitchFamily="34" charset="-122"/>
-                <a:cs typeface="Courier New" pitchFamily="34" charset="-120"/>
-              </a:rPr>
-              <a:t>resource </a:t>
-            </a:r>
-            <a:r>
-              <a:rPr lang="en-US" sz="1250" dirty="0">
-                <a:solidFill>
-                  <a:srgbClr val="9C6621"/>
-                </a:solidFill>
-                <a:latin typeface="Courier New" pitchFamily="34" charset="0"/>
-                <a:ea typeface="Courier New" pitchFamily="34" charset="-122"/>
-                <a:cs typeface="Courier New" pitchFamily="34" charset="-120"/>
-              </a:rPr>
-              <a:t>"aws_iam_role_policy_attachment"</a:t>
-            </a:r>
-            <a:r>
-              <a:rPr lang="en-US" sz="1250" dirty="0">
-                <a:solidFill>
-                  <a:srgbClr val="1F2430"/>
-                </a:solidFill>
-                <a:latin typeface="Courier New" pitchFamily="34" charset="0"/>
-                <a:ea typeface="Courier New" pitchFamily="34" charset="-122"/>
-                <a:cs typeface="Courier New" pitchFamily="34" charset="-120"/>
-              </a:rPr>
-              <a:t> </a:t>
-            </a:r>
-            <a:r>
-              <a:rPr lang="en-US" sz="1250" dirty="0">
-                <a:solidFill>
-                  <a:srgbClr val="9C6621"/>
-                </a:solidFill>
-                <a:latin typeface="Courier New" pitchFamily="34" charset="0"/>
-                <a:ea typeface="Courier New" pitchFamily="34" charset="-122"/>
-                <a:cs typeface="Courier New" pitchFamily="34" charset="-120"/>
-              </a:rPr>
-              <a:t>"attach_s3_read"</a:t>
-            </a:r>
-            <a:r>
-              <a:rPr lang="en-US" sz="1250" dirty="0">
-                <a:solidFill>
-                  <a:srgbClr val="1F2430"/>
-                </a:solidFill>
-                <a:latin typeface="Courier New" pitchFamily="34" charset="0"/>
-                <a:ea typeface="Courier New" pitchFamily="34" charset="-122"/>
-                <a:cs typeface="Courier New" pitchFamily="34" charset="-120"/>
-              </a:rPr>
-              <a:t> {
-  role       </a:t>
-            </a:r>
-            <a:r>
-              <a:rPr lang="en-US" sz="1250" dirty="0">
-                <a:solidFill>
-                  <a:srgbClr val="9AA1AD"/>
-                </a:solidFill>
-                <a:latin typeface="Courier New" pitchFamily="34" charset="0"/>
-                <a:ea typeface="Courier New" pitchFamily="34" charset="-122"/>
-                <a:cs typeface="Courier New" pitchFamily="34" charset="-120"/>
-              </a:rPr>
-              <a:t>= </a:t>
-            </a:r>
-            <a:r>
-              <a:rPr lang="en-US" sz="1250" dirty="0">
-                <a:solidFill>
-                  <a:srgbClr val="3C6E5C"/>
-                </a:solidFill>
-                <a:latin typeface="Courier New" pitchFamily="34" charset="0"/>
-                <a:ea typeface="Courier New" pitchFamily="34" charset="-122"/>
-                <a:cs typeface="Courier New" pitchFamily="34" charset="-120"/>
-              </a:rPr>
-              <a:t>aws_iam_role.app_role.name
-</a:t>
-            </a:r>
-            <a:r>
-              <a:rPr lang="en-US" sz="1250" dirty="0">
-                <a:solidFill>
-                  <a:srgbClr val="1F2430"/>
-                </a:solidFill>
-                <a:latin typeface="Courier New" pitchFamily="34" charset="0"/>
-                <a:ea typeface="Courier New" pitchFamily="34" charset="-122"/>
-                <a:cs typeface="Courier New" pitchFamily="34" charset="-120"/>
-              </a:rPr>
-              <a:t>  policy_arn </a:t>
-            </a:r>
-            <a:r>
-              <a:rPr lang="en-US" sz="1250" dirty="0">
-                <a:solidFill>
-                  <a:srgbClr val="9AA1AD"/>
-                </a:solidFill>
-                <a:latin typeface="Courier New" pitchFamily="34" charset="0"/>
-                <a:ea typeface="Courier New" pitchFamily="34" charset="-122"/>
-                <a:cs typeface="Courier New" pitchFamily="34" charset="-120"/>
-              </a:rPr>
-              <a:t>= </a:t>
-            </a:r>
-            <a:r>
-              <a:rPr lang="en-US" sz="1250" dirty="0">
-                <a:solidFill>
-                  <a:srgbClr val="3C6E5C"/>
-                </a:solidFill>
-                <a:latin typeface="Courier New" pitchFamily="34" charset="0"/>
-                <a:ea typeface="Courier New" pitchFamily="34" charset="-122"/>
-                <a:cs typeface="Courier New" pitchFamily="34" charset="-120"/>
-              </a:rPr>
-              <a:t>aws_iam_policy.s3_read_only.arn
-</a:t>
-            </a:r>
-            <a:r>
-              <a:rPr lang="en-US" sz="1250" dirty="0">
-                <a:solidFill>
-                  <a:srgbClr val="1F2430"/>
-                </a:solidFill>
-                <a:latin typeface="Courier New" pitchFamily="34" charset="0"/>
-                <a:ea typeface="Courier New" pitchFamily="34" charset="-122"/>
-                <a:cs typeface="Courier New" pitchFamily="34" charset="-120"/>
-              </a:rPr>
-              <a:t>}</a:t>
-            </a:r>
-            <a:endParaRPr lang="en-US" sz="1250" dirty="0"/>
-          </a:p>
-        </p:txBody>
-      </p:sp>
-      <p:sp>
-        <p:nvSpPr>
-          <p:cNvPr id="10" name="Text 8"/>
-          <p:cNvSpPr/>
-          <p:nvPr/>
-        </p:nvSpPr>
-        <p:spPr>
-          <a:xfrm>
-            <a:off x="822960" y="4846320"/>
-            <a:ext cx="10543032" cy="457200"/>
-          </a:xfrm>
-          <a:prstGeom prst="rect">
-            <a:avLst/>
-          </a:prstGeom>
-          <a:noFill/>
-          <a:ln/>
-        </p:spPr>
-        <p:txBody>
-          <a:bodyPr wrap="square" rtlCol="0" anchor="ctr"/>
-          <a:lstStyle/>
-          <a:p>
-            <a:pPr marL="0" indent="0">
-              <a:lnSpc>
-                <a:spcPct val="125000"/>
-              </a:lnSpc>
-              <a:buNone/>
-            </a:pPr>
-            <a:r>
-              <a:rPr lang="en-US" sz="1250" dirty="0">
-                <a:solidFill>
-                  <a:srgbClr val="5B6472"/>
-                </a:solidFill>
-                <a:latin typeface="Calibri" pitchFamily="34" charset="0"/>
-                <a:ea typeface="Calibri" pitchFamily="34" charset="-122"/>
-                <a:cs typeface="Calibri" pitchFamily="34" charset="-120"/>
-              </a:rPr>
-              <a:t>A role can have multiple policies attached — effective permissions are their </a:t>
-            </a:r>
-            <a:r>
-              <a:rPr lang="en-US" sz="1250" b="1" i="1" dirty="0">
-                <a:solidFill>
-                  <a:srgbClr val="6E4B84"/>
-                </a:solidFill>
-                <a:latin typeface="Calibri" pitchFamily="34" charset="0"/>
-                <a:ea typeface="Calibri" pitchFamily="34" charset="-122"/>
-                <a:cs typeface="Calibri" pitchFamily="34" charset="-120"/>
-              </a:rPr>
-              <a:t>union</a:t>
-            </a:r>
-            <a:r>
-              <a:rPr lang="en-US" sz="1250" dirty="0">
-                <a:solidFill>
-                  <a:srgbClr val="5B6472"/>
-                </a:solidFill>
-                <a:latin typeface="Calibri" pitchFamily="34" charset="0"/>
-                <a:ea typeface="Calibri" pitchFamily="34" charset="-122"/>
-                <a:cs typeface="Calibri" pitchFamily="34" charset="-120"/>
-              </a:rPr>
-              <a:t>. Explicit deny anywhere wins; otherwise the default is implicit deny.</a:t>
-            </a:r>
-            <a:endParaRPr lang="en-US" sz="1250" dirty="0"/>
-          </a:p>
-        </p:txBody>
-      </p:sp>
-      <p:sp>
-        <p:nvSpPr>
-          <p:cNvPr id="11" name="Shape 9"/>
-          <p:cNvSpPr/>
-          <p:nvPr/>
-        </p:nvSpPr>
-        <p:spPr>
-          <a:xfrm>
-            <a:off x="822960" y="5440680"/>
-            <a:ext cx="10543032" cy="0"/>
-          </a:xfrm>
-          <a:prstGeom prst="line">
-            <a:avLst/>
-          </a:prstGeom>
-          <a:noFill/>
-          <a:ln w="9525">
-            <a:solidFill>
-              <a:srgbClr val="E1E4E9"/>
-            </a:solidFill>
-            <a:prstDash val="solid"/>
-          </a:ln>
-        </p:spPr>
-        <p:txBody>
-          <a:bodyPr/>
-          <a:lstStyle/>
-          <a:p>
-            <a:endParaRPr lang="en-IN"/>
-          </a:p>
-        </p:txBody>
-      </p:sp>
-      <p:sp>
-        <p:nvSpPr>
-          <p:cNvPr id="21" name="Shape 19"/>
-          <p:cNvSpPr/>
-          <p:nvPr/>
-        </p:nvSpPr>
-        <p:spPr>
-          <a:xfrm>
-            <a:off x="822960" y="6419088"/>
-            <a:ext cx="10543032" cy="0"/>
-          </a:xfrm>
-          <a:prstGeom prst="line">
-            <a:avLst/>
-          </a:prstGeom>
-          <a:noFill/>
-          <a:ln w="9525">
-            <a:solidFill>
-              <a:srgbClr val="E1E4E9"/>
-            </a:solidFill>
-            <a:prstDash val="solid"/>
-          </a:ln>
-        </p:spPr>
-        <p:txBody>
-          <a:bodyPr/>
-          <a:lstStyle/>
-          <a:p>
-            <a:endParaRPr lang="en-IN"/>
-          </a:p>
-        </p:txBody>
-      </p:sp>
-    </p:spTree>
-  </p:cSld>
-  <p:clrMapOvr>
-    <a:masterClrMapping/>
-  </p:clrMapOvr>
-</p:sld>
-</file>
-
 <file path=ppt/slides/slide2.xml><?xml version="1.0" encoding="utf-8"?>
 <p:sld xmlns:a="http://schemas.openxmlformats.org/drawingml/2006/main" xmlns:r="http://schemas.openxmlformats.org/officeDocument/2006/relationships" xmlns:p="http://schemas.openxmlformats.org/presentationml/2006/main">
   <p:cSld name="Slide 2">
@@ -3740,216 +3056,6 @@
 
 <file path=ppt/slides/slide4.xml><?xml version="1.0" encoding="utf-8"?>
 <p:sld xmlns:a="http://schemas.openxmlformats.org/drawingml/2006/main" xmlns:r="http://schemas.openxmlformats.org/officeDocument/2006/relationships" xmlns:p="http://schemas.openxmlformats.org/presentationml/2006/main">
-  <p:cSld>
-    <p:spTree>
-      <p:nvGrpSpPr>
-        <p:cNvPr id="1" name=""/>
-        <p:cNvGrpSpPr/>
-        <p:nvPr/>
-      </p:nvGrpSpPr>
-      <p:grpSpPr>
-        <a:xfrm>
-          <a:off x="0" y="0"/>
-          <a:ext cx="0" cy="0"/>
-          <a:chOff x="0" y="0"/>
-          <a:chExt cx="0" cy="0"/>
-        </a:xfrm>
-      </p:grpSpPr>
-      <p:sp>
-        <p:nvSpPr>
-          <p:cNvPr id="2" name="TextBox 1">
-            <a:extLst>
-              <a:ext uri="{FF2B5EF4-FFF2-40B4-BE49-F238E27FC236}">
-                <a16:creationId xmlns:a16="http://schemas.microsoft.com/office/drawing/2014/main" id="{4CB7C250-079B-CFA1-6285-661307522887}"/>
-              </a:ext>
-            </a:extLst>
-          </p:cNvPr>
-          <p:cNvSpPr txBox="1"/>
-          <p:nvPr/>
-        </p:nvSpPr>
-        <p:spPr>
-          <a:xfrm>
-            <a:off x="177800" y="1308100"/>
-            <a:ext cx="5092700" cy="3539430"/>
-          </a:xfrm>
-          <a:prstGeom prst="rect">
-            <a:avLst/>
-          </a:prstGeom>
-          <a:solidFill>
-            <a:schemeClr val="tx2">
-              <a:lumMod val="40000"/>
-              <a:lumOff val="60000"/>
-            </a:schemeClr>
-          </a:solidFill>
-        </p:spPr>
-        <p:txBody>
-          <a:bodyPr wrap="square" rtlCol="0">
-            <a:spAutoFit/>
-          </a:bodyPr>
-          <a:lstStyle/>
-          <a:p>
-            <a:r>
-              <a:rPr lang="en-US" sz="2000" dirty="0"/>
-              <a:t> </a:t>
-            </a:r>
-            <a:r>
-              <a:rPr lang="en-US" sz="2400" b="1" dirty="0"/>
-              <a:t>- </a:t>
-            </a:r>
-            <a:r>
-              <a:rPr lang="en-US" sz="2400" b="1" dirty="0" err="1"/>
-              <a:t>required_version</a:t>
-            </a:r>
-            <a:r>
-              <a:rPr lang="en-US" sz="2400" b="1" dirty="0"/>
-              <a:t> = "&gt;= 1.5" </a:t>
-            </a:r>
-            <a:endParaRPr lang="en-US" sz="2000" b="1" dirty="0"/>
-          </a:p>
-          <a:p>
-            <a:endParaRPr lang="en-US" sz="2000" dirty="0"/>
-          </a:p>
-          <a:p>
-            <a:r>
-              <a:rPr lang="en-US" sz="2000" dirty="0"/>
-              <a:t>— protects against</a:t>
-            </a:r>
-          </a:p>
-          <a:p>
-            <a:r>
-              <a:rPr lang="en-US" sz="2000" dirty="0"/>
-              <a:t>  someone running your config with an old Terraform  CLI that doesn't understand a language feature   </a:t>
-            </a:r>
-          </a:p>
-          <a:p>
-            <a:r>
-              <a:rPr lang="en-US" sz="2000" dirty="0"/>
-              <a:t>  you used (e.g. import blocks, which need 1.5+).</a:t>
-            </a:r>
-          </a:p>
-          <a:p>
-            <a:r>
-              <a:rPr lang="en-US" sz="2000" dirty="0"/>
-              <a:t>  Without it, you'd get a confusing parse error    </a:t>
-            </a:r>
-          </a:p>
-          <a:p>
-            <a:r>
-              <a:rPr lang="en-US" sz="2000" dirty="0"/>
-              <a:t>  instead of a clear "your Terraform is too old"</a:t>
-            </a:r>
-          </a:p>
-          <a:p>
-            <a:r>
-              <a:rPr lang="en-US" sz="2000" dirty="0"/>
-              <a:t>  message.</a:t>
-            </a:r>
-            <a:endParaRPr lang="en-IN" sz="2000" dirty="0"/>
-          </a:p>
-        </p:txBody>
-      </p:sp>
-      <p:sp>
-        <p:nvSpPr>
-          <p:cNvPr id="3" name="TextBox 2">
-            <a:extLst>
-              <a:ext uri="{FF2B5EF4-FFF2-40B4-BE49-F238E27FC236}">
-                <a16:creationId xmlns:a16="http://schemas.microsoft.com/office/drawing/2014/main" id="{EBB707C7-4C7C-BB49-0E98-2A87C9FCB21B}"/>
-              </a:ext>
-            </a:extLst>
-          </p:cNvPr>
-          <p:cNvSpPr txBox="1"/>
-          <p:nvPr/>
-        </p:nvSpPr>
-        <p:spPr>
-          <a:xfrm>
-            <a:off x="6096000" y="2133073"/>
-            <a:ext cx="6096000" cy="1323439"/>
-          </a:xfrm>
-          <a:prstGeom prst="rect">
-            <a:avLst/>
-          </a:prstGeom>
-          <a:solidFill>
-            <a:schemeClr val="accent1">
-              <a:lumMod val="20000"/>
-              <a:lumOff val="80000"/>
-            </a:schemeClr>
-          </a:solidFill>
-        </p:spPr>
-        <p:txBody>
-          <a:bodyPr wrap="square" rtlCol="0">
-            <a:spAutoFit/>
-          </a:bodyPr>
-          <a:lstStyle/>
-          <a:p>
-            <a:pPr marL="285750" indent="-285750">
-              <a:buFontTx/>
-              <a:buChar char="-"/>
-            </a:pPr>
-            <a:r>
-              <a:rPr lang="en-US" sz="2000" b="1" dirty="0" err="1"/>
-              <a:t>required_providers</a:t>
-            </a:r>
-            <a:r>
-              <a:rPr lang="en-US" sz="2000" b="1" dirty="0"/>
-              <a:t> { </a:t>
-            </a:r>
-            <a:r>
-              <a:rPr lang="en-US" sz="2000" b="1" dirty="0" err="1"/>
-              <a:t>aws</a:t>
-            </a:r>
-            <a:r>
-              <a:rPr lang="en-US" sz="2000" b="1" dirty="0"/>
-              <a:t> = { version = "~&gt; 5.0"  } } </a:t>
-            </a:r>
-          </a:p>
-          <a:p>
-            <a:pPr marL="285750" indent="-285750">
-              <a:buFontTx/>
-              <a:buChar char="-"/>
-            </a:pPr>
-            <a:r>
-              <a:rPr lang="en-US" sz="2000" dirty="0"/>
-              <a:t>— protects against terraform </a:t>
-            </a:r>
-            <a:r>
-              <a:rPr lang="en-US" sz="2000" dirty="0" err="1"/>
-              <a:t>init</a:t>
-            </a:r>
-            <a:r>
-              <a:rPr lang="en-US" sz="2000" dirty="0"/>
-              <a:t> silently   </a:t>
-            </a:r>
-          </a:p>
-          <a:p>
-            <a:r>
-              <a:rPr lang="en-US" sz="2000" dirty="0"/>
-              <a:t>  grabbing AWS provider 6.0 someday and breaking</a:t>
-            </a:r>
-          </a:p>
-          <a:p>
-            <a:r>
-              <a:rPr lang="en-US" sz="2000" dirty="0"/>
-              <a:t>  your code with its renamed resources/arguments</a:t>
-            </a:r>
-            <a:endParaRPr lang="en-IN" sz="2000" dirty="0"/>
-          </a:p>
-        </p:txBody>
-      </p:sp>
-    </p:spTree>
-    <p:extLst>
-      <p:ext uri="{BB962C8B-B14F-4D97-AF65-F5344CB8AC3E}">
-        <p14:creationId xmlns:p14="http://schemas.microsoft.com/office/powerpoint/2010/main" val="3292135915"/>
-      </p:ext>
-    </p:extLst>
-  </p:cSld>
-  <p:clrMapOvr>
-    <a:masterClrMapping/>
-  </p:clrMapOvr>
-</p:sld>
-</file>
-
-<file path=ppt/slides/slide5.xml><?xml version="1.0" encoding="utf-8"?>
-<p:sld xmlns:a="http://schemas.openxmlformats.org/drawingml/2006/main" xmlns:r="http://schemas.openxmlformats.org/officeDocument/2006/relationships" xmlns:p="http://schemas.openxmlformats.org/presentationml/2006/main">
   <p:cSld name="Slide 4">
     <p:bg>
       <p:bgPr>
@@ -4439,7 +3545,7 @@
 </p:sld>
 </file>
 
-<file path=ppt/slides/slide6.xml><?xml version="1.0" encoding="utf-8"?>
+<file path=ppt/slides/slide5.xml><?xml version="1.0" encoding="utf-8"?>
 <p:sld xmlns:a="http://schemas.openxmlformats.org/drawingml/2006/main" xmlns:r="http://schemas.openxmlformats.org/officeDocument/2006/relationships" xmlns:p="http://schemas.openxmlformats.org/presentationml/2006/main">
   <p:cSld name="Slide 6">
     <p:bg>
@@ -5158,7 +4264,7 @@
 </p:sld>
 </file>
 
-<file path=ppt/slides/slide7.xml><?xml version="1.0" encoding="utf-8"?>
+<file path=ppt/slides/slide6.xml><?xml version="1.0" encoding="utf-8"?>
 <p:sld xmlns:a="http://schemas.openxmlformats.org/drawingml/2006/main" xmlns:r="http://schemas.openxmlformats.org/officeDocument/2006/relationships" xmlns:p="http://schemas.openxmlformats.org/presentationml/2006/main">
   <p:cSld name="Slide 8">
     <p:bg>
@@ -5471,7 +4577,7 @@
 </p:sld>
 </file>
 
-<file path=ppt/slides/slide8.xml><?xml version="1.0" encoding="utf-8"?>
+<file path=ppt/slides/slide7.xml><?xml version="1.0" encoding="utf-8"?>
 <p:sld xmlns:a="http://schemas.openxmlformats.org/drawingml/2006/main" xmlns:r="http://schemas.openxmlformats.org/officeDocument/2006/relationships" xmlns:p="http://schemas.openxmlformats.org/presentationml/2006/main">
   <p:cSld name="Slide 9">
     <p:bg>
@@ -6119,7 +5225,7 @@
 </p:sld>
 </file>
 
-<file path=ppt/slides/slide9.xml><?xml version="1.0" encoding="utf-8"?>
+<file path=ppt/slides/slide8.xml><?xml version="1.0" encoding="utf-8"?>
 <p:sld xmlns:a="http://schemas.openxmlformats.org/drawingml/2006/main" xmlns:r="http://schemas.openxmlformats.org/officeDocument/2006/relationships" xmlns:p="http://schemas.openxmlformats.org/presentationml/2006/main">
   <p:cSld name="Slide 10">
     <p:bg>
@@ -7144,6 +6250,689 @@
               <a:t>is   "let Terraform help me build the JSON correctly."</a:t>
             </a:r>
             <a:endParaRPr lang="en-IN" dirty="0"/>
+          </a:p>
+        </p:txBody>
+      </p:sp>
+    </p:spTree>
+  </p:cSld>
+  <p:clrMapOvr>
+    <a:masterClrMapping/>
+  </p:clrMapOvr>
+</p:sld>
+</file>
+
+<file path=ppt/slides/slide9.xml><?xml version="1.0" encoding="utf-8"?>
+<p:sld xmlns:a="http://schemas.openxmlformats.org/drawingml/2006/main" xmlns:r="http://schemas.openxmlformats.org/officeDocument/2006/relationships" xmlns:p="http://schemas.openxmlformats.org/presentationml/2006/main">
+  <p:cSld name="Slide 11">
+    <p:bg>
+      <p:bgPr>
+        <a:solidFill>
+          <a:srgbClr val="FFFFFF"/>
+        </a:solidFill>
+        <a:effectLst/>
+      </p:bgPr>
+    </p:bg>
+    <p:spTree>
+      <p:nvGrpSpPr>
+        <p:cNvPr id="1" name=""/>
+        <p:cNvGrpSpPr/>
+        <p:nvPr/>
+      </p:nvGrpSpPr>
+      <p:grpSpPr>
+        <a:xfrm>
+          <a:off x="0" y="0"/>
+          <a:ext cx="0" cy="0"/>
+          <a:chOff x="0" y="0"/>
+          <a:chExt cx="0" cy="0"/>
+        </a:xfrm>
+      </p:grpSpPr>
+      <p:sp>
+        <p:nvSpPr>
+          <p:cNvPr id="2" name="Text 0"/>
+          <p:cNvSpPr/>
+          <p:nvPr/>
+        </p:nvSpPr>
+        <p:spPr>
+          <a:xfrm>
+            <a:off x="7955280" y="-502920"/>
+            <a:ext cx="3383280" cy="2377440"/>
+          </a:xfrm>
+          <a:prstGeom prst="rect">
+            <a:avLst/>
+          </a:prstGeom>
+          <a:noFill/>
+          <a:ln/>
+        </p:spPr>
+        <p:txBody>
+          <a:bodyPr wrap="square" rtlCol="0" anchor="ctr"/>
+          <a:lstStyle/>
+          <a:p>
+            <a:pPr marL="0" indent="0" algn="r">
+              <a:buNone/>
+            </a:pPr>
+            <a:r>
+              <a:rPr lang="en-US" sz="15000" b="1" dirty="0">
+                <a:solidFill>
+                  <a:srgbClr val="EEEFF3"/>
+                </a:solidFill>
+                <a:latin typeface="Century Schoolbook" pitchFamily="34" charset="0"/>
+                <a:ea typeface="Century Schoolbook" pitchFamily="34" charset="-122"/>
+                <a:cs typeface="Century Schoolbook" pitchFamily="34" charset="-120"/>
+              </a:rPr>
+              <a:t>09</a:t>
+            </a:r>
+            <a:endParaRPr lang="en-US" sz="15000" dirty="0"/>
+          </a:p>
+        </p:txBody>
+      </p:sp>
+      <p:sp>
+        <p:nvSpPr>
+          <p:cNvPr id="3" name="Shape 1"/>
+          <p:cNvSpPr/>
+          <p:nvPr/>
+        </p:nvSpPr>
+        <p:spPr>
+          <a:xfrm>
+            <a:off x="822960" y="868680"/>
+            <a:ext cx="137160" cy="137160"/>
+          </a:xfrm>
+          <a:prstGeom prst="rect">
+            <a:avLst/>
+          </a:prstGeom>
+          <a:solidFill>
+            <a:srgbClr val="6E4B84"/>
+          </a:solidFill>
+          <a:ln/>
+        </p:spPr>
+        <p:txBody>
+          <a:bodyPr/>
+          <a:lstStyle/>
+          <a:p>
+            <a:endParaRPr lang="en-IN"/>
+          </a:p>
+        </p:txBody>
+      </p:sp>
+      <p:sp>
+        <p:nvSpPr>
+          <p:cNvPr id="4" name="Text 2"/>
+          <p:cNvSpPr/>
+          <p:nvPr/>
+        </p:nvSpPr>
+        <p:spPr>
+          <a:xfrm>
+            <a:off x="1078992" y="795528"/>
+            <a:ext cx="8229600" cy="292608"/>
+          </a:xfrm>
+          <a:prstGeom prst="rect">
+            <a:avLst/>
+          </a:prstGeom>
+          <a:noFill/>
+          <a:ln/>
+        </p:spPr>
+        <p:txBody>
+          <a:bodyPr wrap="square" rtlCol="0" anchor="ctr"/>
+          <a:lstStyle/>
+          <a:p>
+            <a:pPr marL="0" indent="0">
+              <a:buNone/>
+            </a:pPr>
+            <a:r>
+              <a:rPr lang="en-US" sz="1100" b="1" kern="0" spc="250" dirty="0">
+                <a:solidFill>
+                  <a:srgbClr val="6E4B84"/>
+                </a:solidFill>
+                <a:latin typeface="Calibri" pitchFamily="34" charset="0"/>
+                <a:ea typeface="Calibri" pitchFamily="34" charset="-122"/>
+                <a:cs typeface="Calibri" pitchFamily="34" charset="-120"/>
+              </a:rPr>
+              <a:t>THE STEP THAT'S EASY TO FORGET</a:t>
+            </a:r>
+            <a:endParaRPr lang="en-US" sz="1100" dirty="0"/>
+          </a:p>
+        </p:txBody>
+      </p:sp>
+      <p:sp>
+        <p:nvSpPr>
+          <p:cNvPr id="5" name="Text 3"/>
+          <p:cNvSpPr/>
+          <p:nvPr/>
+        </p:nvSpPr>
+        <p:spPr>
+          <a:xfrm>
+            <a:off x="795528" y="1115568"/>
+            <a:ext cx="8778240" cy="822960"/>
+          </a:xfrm>
+          <a:prstGeom prst="rect">
+            <a:avLst/>
+          </a:prstGeom>
+          <a:noFill/>
+          <a:ln/>
+        </p:spPr>
+        <p:txBody>
+          <a:bodyPr wrap="square" rtlCol="0" anchor="ctr"/>
+          <a:lstStyle/>
+          <a:p>
+            <a:pPr marL="0" indent="0">
+              <a:buNone/>
+            </a:pPr>
+            <a:r>
+              <a:rPr lang="en-US" sz="3300" b="1" dirty="0">
+                <a:solidFill>
+                  <a:srgbClr val="1F2430"/>
+                </a:solidFill>
+                <a:latin typeface="Century Schoolbook" pitchFamily="34" charset="0"/>
+                <a:ea typeface="Century Schoolbook" pitchFamily="34" charset="-122"/>
+                <a:cs typeface="Century Schoolbook" pitchFamily="34" charset="-120"/>
+              </a:rPr>
+              <a:t>Attaching a policy to a role</a:t>
+            </a:r>
+            <a:endParaRPr lang="en-US" sz="3300" dirty="0"/>
+          </a:p>
+        </p:txBody>
+      </p:sp>
+      <p:sp>
+        <p:nvSpPr>
+          <p:cNvPr id="6" name="Shape 4"/>
+          <p:cNvSpPr/>
+          <p:nvPr/>
+        </p:nvSpPr>
+        <p:spPr>
+          <a:xfrm>
+            <a:off x="822960" y="2148840"/>
+            <a:ext cx="10543032" cy="2514600"/>
+          </a:xfrm>
+          <a:prstGeom prst="roundRect">
+            <a:avLst>
+              <a:gd name="adj" fmla="val 2182"/>
+            </a:avLst>
+          </a:prstGeom>
+          <a:solidFill>
+            <a:srgbClr val="F6F7F9"/>
+          </a:solidFill>
+          <a:ln w="12700">
+            <a:solidFill>
+              <a:srgbClr val="E1E4E9"/>
+            </a:solidFill>
+            <a:prstDash val="solid"/>
+          </a:ln>
+        </p:spPr>
+        <p:txBody>
+          <a:bodyPr/>
+          <a:lstStyle/>
+          <a:p>
+            <a:endParaRPr lang="en-IN"/>
+          </a:p>
+        </p:txBody>
+      </p:sp>
+      <p:sp>
+        <p:nvSpPr>
+          <p:cNvPr id="7" name="Shape 5"/>
+          <p:cNvSpPr/>
+          <p:nvPr/>
+        </p:nvSpPr>
+        <p:spPr>
+          <a:xfrm>
+            <a:off x="1051560" y="2002536"/>
+            <a:ext cx="947318" cy="310896"/>
+          </a:xfrm>
+          <a:prstGeom prst="roundRect">
+            <a:avLst>
+              <a:gd name="adj" fmla="val 14706"/>
+            </a:avLst>
+          </a:prstGeom>
+          <a:solidFill>
+            <a:srgbClr val="1F2430"/>
+          </a:solidFill>
+          <a:ln/>
+        </p:spPr>
+        <p:txBody>
+          <a:bodyPr/>
+          <a:lstStyle/>
+          <a:p>
+            <a:endParaRPr lang="en-IN"/>
+          </a:p>
+        </p:txBody>
+      </p:sp>
+      <p:sp>
+        <p:nvSpPr>
+          <p:cNvPr id="8" name="Text 6"/>
+          <p:cNvSpPr/>
+          <p:nvPr/>
+        </p:nvSpPr>
+        <p:spPr>
+          <a:xfrm>
+            <a:off x="1051560" y="2002536"/>
+            <a:ext cx="947318" cy="310896"/>
+          </a:xfrm>
+          <a:prstGeom prst="rect">
+            <a:avLst/>
+          </a:prstGeom>
+          <a:noFill/>
+          <a:ln/>
+        </p:spPr>
+        <p:txBody>
+          <a:bodyPr wrap="square" rtlCol="0" anchor="ctr"/>
+          <a:lstStyle/>
+          <a:p>
+            <a:pPr marL="0" indent="0" algn="ctr">
+              <a:buNone/>
+            </a:pPr>
+            <a:r>
+              <a:rPr lang="en-US" sz="1000" dirty="0">
+                <a:solidFill>
+                  <a:srgbClr val="FFFFFF"/>
+                </a:solidFill>
+                <a:latin typeface="Courier New" pitchFamily="34" charset="0"/>
+                <a:ea typeface="Courier New" pitchFamily="34" charset="-122"/>
+                <a:cs typeface="Courier New" pitchFamily="34" charset="-120"/>
+              </a:rPr>
+              <a:t>main.tf</a:t>
+            </a:r>
+            <a:endParaRPr lang="en-US" sz="1000" dirty="0"/>
+          </a:p>
+        </p:txBody>
+      </p:sp>
+      <p:sp>
+        <p:nvSpPr>
+          <p:cNvPr id="9" name="Text 7"/>
+          <p:cNvSpPr/>
+          <p:nvPr/>
+        </p:nvSpPr>
+        <p:spPr>
+          <a:xfrm>
+            <a:off x="1097280" y="2459736"/>
+            <a:ext cx="9994392" cy="2057400"/>
+          </a:xfrm>
+          <a:prstGeom prst="rect">
+            <a:avLst/>
+          </a:prstGeom>
+          <a:noFill/>
+          <a:ln/>
+        </p:spPr>
+        <p:txBody>
+          <a:bodyPr wrap="square" rtlCol="0" anchor="t"/>
+          <a:lstStyle/>
+          <a:p>
+            <a:pPr marL="0" indent="0" algn="l">
+              <a:lnSpc>
+                <a:spcPct val="118000"/>
+              </a:lnSpc>
+              <a:buNone/>
+            </a:pPr>
+            <a:r>
+              <a:rPr lang="en-US" sz="1250" dirty="0">
+                <a:solidFill>
+                  <a:srgbClr val="2E5A7E"/>
+                </a:solidFill>
+                <a:latin typeface="Courier New" pitchFamily="34" charset="0"/>
+                <a:ea typeface="Courier New" pitchFamily="34" charset="-122"/>
+                <a:cs typeface="Courier New" pitchFamily="34" charset="-120"/>
+              </a:rPr>
+              <a:t>resource </a:t>
+            </a:r>
+            <a:r>
+              <a:rPr lang="en-US" sz="1250" dirty="0">
+                <a:solidFill>
+                  <a:srgbClr val="9C6621"/>
+                </a:solidFill>
+                <a:latin typeface="Courier New" pitchFamily="34" charset="0"/>
+                <a:ea typeface="Courier New" pitchFamily="34" charset="-122"/>
+                <a:cs typeface="Courier New" pitchFamily="34" charset="-120"/>
+              </a:rPr>
+              <a:t>"aws_iam_policy"</a:t>
+            </a:r>
+            <a:r>
+              <a:rPr lang="en-US" sz="1250" dirty="0">
+                <a:solidFill>
+                  <a:srgbClr val="1F2430"/>
+                </a:solidFill>
+                <a:latin typeface="Courier New" pitchFamily="34" charset="0"/>
+                <a:ea typeface="Courier New" pitchFamily="34" charset="-122"/>
+                <a:cs typeface="Courier New" pitchFamily="34" charset="-120"/>
+              </a:rPr>
+              <a:t> </a:t>
+            </a:r>
+            <a:r>
+              <a:rPr lang="en-US" sz="1250" dirty="0">
+                <a:solidFill>
+                  <a:srgbClr val="9C6621"/>
+                </a:solidFill>
+                <a:latin typeface="Courier New" pitchFamily="34" charset="0"/>
+                <a:ea typeface="Courier New" pitchFamily="34" charset="-122"/>
+                <a:cs typeface="Courier New" pitchFamily="34" charset="-120"/>
+              </a:rPr>
+              <a:t>"s3_read_only"</a:t>
+            </a:r>
+            <a:r>
+              <a:rPr lang="en-US" sz="1250" dirty="0">
+                <a:solidFill>
+                  <a:srgbClr val="1F2430"/>
+                </a:solidFill>
+                <a:latin typeface="Courier New" pitchFamily="34" charset="0"/>
+                <a:ea typeface="Courier New" pitchFamily="34" charset="-122"/>
+                <a:cs typeface="Courier New" pitchFamily="34" charset="-120"/>
+              </a:rPr>
+              <a:t> {
+  name   </a:t>
+            </a:r>
+            <a:r>
+              <a:rPr lang="en-US" sz="1250" dirty="0">
+                <a:solidFill>
+                  <a:srgbClr val="9AA1AD"/>
+                </a:solidFill>
+                <a:latin typeface="Courier New" pitchFamily="34" charset="0"/>
+                <a:ea typeface="Courier New" pitchFamily="34" charset="-122"/>
+                <a:cs typeface="Courier New" pitchFamily="34" charset="-120"/>
+              </a:rPr>
+              <a:t>= </a:t>
+            </a:r>
+            <a:r>
+              <a:rPr lang="en-US" sz="1250" dirty="0">
+                <a:solidFill>
+                  <a:srgbClr val="9C6621"/>
+                </a:solidFill>
+                <a:latin typeface="Courier New" pitchFamily="34" charset="0"/>
+                <a:ea typeface="Courier New" pitchFamily="34" charset="-122"/>
+                <a:cs typeface="Courier New" pitchFamily="34" charset="-120"/>
+              </a:rPr>
+              <a:t>"my-role-s3-read-only"
+</a:t>
+            </a:r>
+            <a:r>
+              <a:rPr lang="en-US" sz="1250" dirty="0">
+                <a:solidFill>
+                  <a:srgbClr val="1F2430"/>
+                </a:solidFill>
+                <a:latin typeface="Courier New" pitchFamily="34" charset="0"/>
+                <a:ea typeface="Courier New" pitchFamily="34" charset="-122"/>
+                <a:cs typeface="Courier New" pitchFamily="34" charset="-120"/>
+              </a:rPr>
+              <a:t>  policy </a:t>
+            </a:r>
+            <a:r>
+              <a:rPr lang="en-US" sz="1250" dirty="0">
+                <a:solidFill>
+                  <a:srgbClr val="9AA1AD"/>
+                </a:solidFill>
+                <a:latin typeface="Courier New" pitchFamily="34" charset="0"/>
+                <a:ea typeface="Courier New" pitchFamily="34" charset="-122"/>
+                <a:cs typeface="Courier New" pitchFamily="34" charset="-120"/>
+              </a:rPr>
+              <a:t>= </a:t>
+            </a:r>
+            <a:r>
+              <a:rPr lang="en-US" sz="1250" dirty="0">
+                <a:solidFill>
+                  <a:srgbClr val="3C6E5C"/>
+                </a:solidFill>
+                <a:latin typeface="Courier New" pitchFamily="34" charset="0"/>
+                <a:ea typeface="Courier New" pitchFamily="34" charset="-122"/>
+                <a:cs typeface="Courier New" pitchFamily="34" charset="-120"/>
+              </a:rPr>
+              <a:t>data.aws_iam_policy_document.s3_read_only.json
+</a:t>
+            </a:r>
+            <a:r>
+              <a:rPr lang="en-US" sz="1250" dirty="0">
+                <a:solidFill>
+                  <a:srgbClr val="1F2430"/>
+                </a:solidFill>
+                <a:latin typeface="Courier New" pitchFamily="34" charset="0"/>
+                <a:ea typeface="Courier New" pitchFamily="34" charset="-122"/>
+                <a:cs typeface="Courier New" pitchFamily="34" charset="-120"/>
+              </a:rPr>
+              <a:t>}
+</a:t>
+            </a:r>
+            <a:r>
+              <a:rPr lang="en-US" sz="1250" dirty="0">
+                <a:solidFill>
+                  <a:srgbClr val="2E5A7E"/>
+                </a:solidFill>
+                <a:latin typeface="Courier New" pitchFamily="34" charset="0"/>
+                <a:ea typeface="Courier New" pitchFamily="34" charset="-122"/>
+                <a:cs typeface="Courier New" pitchFamily="34" charset="-120"/>
+              </a:rPr>
+              <a:t>resource </a:t>
+            </a:r>
+            <a:r>
+              <a:rPr lang="en-US" sz="1250" dirty="0">
+                <a:solidFill>
+                  <a:srgbClr val="9C6621"/>
+                </a:solidFill>
+                <a:latin typeface="Courier New" pitchFamily="34" charset="0"/>
+                <a:ea typeface="Courier New" pitchFamily="34" charset="-122"/>
+                <a:cs typeface="Courier New" pitchFamily="34" charset="-120"/>
+              </a:rPr>
+              <a:t>"aws_iam_role_policy_attachment"</a:t>
+            </a:r>
+            <a:r>
+              <a:rPr lang="en-US" sz="1250" dirty="0">
+                <a:solidFill>
+                  <a:srgbClr val="1F2430"/>
+                </a:solidFill>
+                <a:latin typeface="Courier New" pitchFamily="34" charset="0"/>
+                <a:ea typeface="Courier New" pitchFamily="34" charset="-122"/>
+                <a:cs typeface="Courier New" pitchFamily="34" charset="-120"/>
+              </a:rPr>
+              <a:t> </a:t>
+            </a:r>
+            <a:r>
+              <a:rPr lang="en-US" sz="1250" dirty="0">
+                <a:solidFill>
+                  <a:srgbClr val="9C6621"/>
+                </a:solidFill>
+                <a:latin typeface="Courier New" pitchFamily="34" charset="0"/>
+                <a:ea typeface="Courier New" pitchFamily="34" charset="-122"/>
+                <a:cs typeface="Courier New" pitchFamily="34" charset="-120"/>
+              </a:rPr>
+              <a:t>"attach_s3_read"</a:t>
+            </a:r>
+            <a:r>
+              <a:rPr lang="en-US" sz="1250" dirty="0">
+                <a:solidFill>
+                  <a:srgbClr val="1F2430"/>
+                </a:solidFill>
+                <a:latin typeface="Courier New" pitchFamily="34" charset="0"/>
+                <a:ea typeface="Courier New" pitchFamily="34" charset="-122"/>
+                <a:cs typeface="Courier New" pitchFamily="34" charset="-120"/>
+              </a:rPr>
+              <a:t> {
+  role       </a:t>
+            </a:r>
+            <a:r>
+              <a:rPr lang="en-US" sz="1250" dirty="0">
+                <a:solidFill>
+                  <a:srgbClr val="9AA1AD"/>
+                </a:solidFill>
+                <a:latin typeface="Courier New" pitchFamily="34" charset="0"/>
+                <a:ea typeface="Courier New" pitchFamily="34" charset="-122"/>
+                <a:cs typeface="Courier New" pitchFamily="34" charset="-120"/>
+              </a:rPr>
+              <a:t>= </a:t>
+            </a:r>
+            <a:r>
+              <a:rPr lang="en-US" sz="1250" dirty="0">
+                <a:solidFill>
+                  <a:srgbClr val="3C6E5C"/>
+                </a:solidFill>
+                <a:latin typeface="Courier New" pitchFamily="34" charset="0"/>
+                <a:ea typeface="Courier New" pitchFamily="34" charset="-122"/>
+                <a:cs typeface="Courier New" pitchFamily="34" charset="-120"/>
+              </a:rPr>
+              <a:t>aws_iam_role.app_role.name
+</a:t>
+            </a:r>
+            <a:r>
+              <a:rPr lang="en-US" sz="1250" dirty="0">
+                <a:solidFill>
+                  <a:srgbClr val="1F2430"/>
+                </a:solidFill>
+                <a:latin typeface="Courier New" pitchFamily="34" charset="0"/>
+                <a:ea typeface="Courier New" pitchFamily="34" charset="-122"/>
+                <a:cs typeface="Courier New" pitchFamily="34" charset="-120"/>
+              </a:rPr>
+              <a:t>  policy_arn </a:t>
+            </a:r>
+            <a:r>
+              <a:rPr lang="en-US" sz="1250" dirty="0">
+                <a:solidFill>
+                  <a:srgbClr val="9AA1AD"/>
+                </a:solidFill>
+                <a:latin typeface="Courier New" pitchFamily="34" charset="0"/>
+                <a:ea typeface="Courier New" pitchFamily="34" charset="-122"/>
+                <a:cs typeface="Courier New" pitchFamily="34" charset="-120"/>
+              </a:rPr>
+              <a:t>= </a:t>
+            </a:r>
+            <a:r>
+              <a:rPr lang="en-US" sz="1250" dirty="0">
+                <a:solidFill>
+                  <a:srgbClr val="3C6E5C"/>
+                </a:solidFill>
+                <a:latin typeface="Courier New" pitchFamily="34" charset="0"/>
+                <a:ea typeface="Courier New" pitchFamily="34" charset="-122"/>
+                <a:cs typeface="Courier New" pitchFamily="34" charset="-120"/>
+              </a:rPr>
+              <a:t>aws_iam_policy.s3_read_only.arn
+</a:t>
+            </a:r>
+            <a:r>
+              <a:rPr lang="en-US" sz="1250" dirty="0">
+                <a:solidFill>
+                  <a:srgbClr val="1F2430"/>
+                </a:solidFill>
+                <a:latin typeface="Courier New" pitchFamily="34" charset="0"/>
+                <a:ea typeface="Courier New" pitchFamily="34" charset="-122"/>
+                <a:cs typeface="Courier New" pitchFamily="34" charset="-120"/>
+              </a:rPr>
+              <a:t>}</a:t>
+            </a:r>
+            <a:endParaRPr lang="en-US" sz="1250" dirty="0"/>
+          </a:p>
+        </p:txBody>
+      </p:sp>
+      <p:sp>
+        <p:nvSpPr>
+          <p:cNvPr id="10" name="Text 8"/>
+          <p:cNvSpPr/>
+          <p:nvPr/>
+        </p:nvSpPr>
+        <p:spPr>
+          <a:xfrm>
+            <a:off x="822960" y="4846320"/>
+            <a:ext cx="10543032" cy="457200"/>
+          </a:xfrm>
+          <a:prstGeom prst="rect">
+            <a:avLst/>
+          </a:prstGeom>
+          <a:noFill/>
+          <a:ln/>
+        </p:spPr>
+        <p:txBody>
+          <a:bodyPr wrap="square" rtlCol="0" anchor="ctr"/>
+          <a:lstStyle/>
+          <a:p>
+            <a:pPr marL="0" indent="0">
+              <a:lnSpc>
+                <a:spcPct val="125000"/>
+              </a:lnSpc>
+              <a:buNone/>
+            </a:pPr>
+            <a:r>
+              <a:rPr lang="en-US" sz="1250" dirty="0">
+                <a:solidFill>
+                  <a:srgbClr val="5B6472"/>
+                </a:solidFill>
+                <a:latin typeface="Calibri" pitchFamily="34" charset="0"/>
+                <a:ea typeface="Calibri" pitchFamily="34" charset="-122"/>
+                <a:cs typeface="Calibri" pitchFamily="34" charset="-120"/>
+              </a:rPr>
+              <a:t>A role can have multiple policies attached — effective permissions are their </a:t>
+            </a:r>
+            <a:r>
+              <a:rPr lang="en-US" sz="1250" b="1" i="1" dirty="0">
+                <a:solidFill>
+                  <a:srgbClr val="6E4B84"/>
+                </a:solidFill>
+                <a:latin typeface="Calibri" pitchFamily="34" charset="0"/>
+                <a:ea typeface="Calibri" pitchFamily="34" charset="-122"/>
+                <a:cs typeface="Calibri" pitchFamily="34" charset="-120"/>
+              </a:rPr>
+              <a:t>union</a:t>
+            </a:r>
+            <a:r>
+              <a:rPr lang="en-US" sz="1250" dirty="0">
+                <a:solidFill>
+                  <a:srgbClr val="5B6472"/>
+                </a:solidFill>
+                <a:latin typeface="Calibri" pitchFamily="34" charset="0"/>
+                <a:ea typeface="Calibri" pitchFamily="34" charset="-122"/>
+                <a:cs typeface="Calibri" pitchFamily="34" charset="-120"/>
+              </a:rPr>
+              <a:t>. Explicit deny anywhere wins; otherwise the default is implicit deny.</a:t>
+            </a:r>
+            <a:endParaRPr lang="en-US" sz="1250" dirty="0"/>
+          </a:p>
+        </p:txBody>
+      </p:sp>
+      <p:sp>
+        <p:nvSpPr>
+          <p:cNvPr id="11" name="Shape 9"/>
+          <p:cNvSpPr/>
+          <p:nvPr/>
+        </p:nvSpPr>
+        <p:spPr>
+          <a:xfrm>
+            <a:off x="822960" y="5440680"/>
+            <a:ext cx="10543032" cy="0"/>
+          </a:xfrm>
+          <a:prstGeom prst="line">
+            <a:avLst/>
+          </a:prstGeom>
+          <a:noFill/>
+          <a:ln w="9525">
+            <a:solidFill>
+              <a:srgbClr val="E1E4E9"/>
+            </a:solidFill>
+            <a:prstDash val="solid"/>
+          </a:ln>
+        </p:spPr>
+        <p:txBody>
+          <a:bodyPr/>
+          <a:lstStyle/>
+          <a:p>
+            <a:endParaRPr lang="en-IN"/>
+          </a:p>
+        </p:txBody>
+      </p:sp>
+      <p:sp>
+        <p:nvSpPr>
+          <p:cNvPr id="21" name="Shape 19"/>
+          <p:cNvSpPr/>
+          <p:nvPr/>
+        </p:nvSpPr>
+        <p:spPr>
+          <a:xfrm>
+            <a:off x="822960" y="6419088"/>
+            <a:ext cx="10543032" cy="0"/>
+          </a:xfrm>
+          <a:prstGeom prst="line">
+            <a:avLst/>
+          </a:prstGeom>
+          <a:noFill/>
+          <a:ln w="9525">
+            <a:solidFill>
+              <a:srgbClr val="E1E4E9"/>
+            </a:solidFill>
+            <a:prstDash val="solid"/>
+          </a:ln>
+        </p:spPr>
+        <p:txBody>
+          <a:bodyPr/>
+          <a:lstStyle/>
+          <a:p>
+            <a:endParaRPr lang="en-IN"/>
           </a:p>
         </p:txBody>
       </p:sp>

</xml_diff>